<commit_message>
docs: update HiCache research materials and graduate study notes
</commit_message>
<xml_diff>
--- a/01_Projects_项目/10月9日向唐老师汇报用材料/许世鹏PPT.pptx
+++ b/01_Projects_项目/10月9日向唐老师汇报用材料/许世鹏PPT.pptx
@@ -119,12 +119,12 @@
   <p:extLst>
     <p:ext uri="{EFAFB233-063F-42B5-8137-9DF3F51BA10A}">
       <p15:sldGuideLst xmlns:p15="http://schemas.microsoft.com/office/powerpoint/2012/main">
-        <p15:guide id="1" orient="horz" pos="2034" userDrawn="1">
+        <p15:guide id="1" orient="horz" pos="2066" userDrawn="1">
           <p15:clr>
             <a:srgbClr val="A4A3A4"/>
           </p15:clr>
         </p15:guide>
-        <p15:guide id="2" pos="3846" userDrawn="1">
+        <p15:guide id="2" pos="3840" userDrawn="1">
           <p15:clr>
             <a:srgbClr val="A4A3A4"/>
           </p15:clr>
@@ -6700,9 +6700,607 @@
           </a:p>
         </p:txBody>
       </p:sp>
+      <p:sp>
+        <p:nvSpPr>
+          <p:cNvPr id="32" name="矩形 31"/>
+          <p:cNvSpPr>
+            <a:spLocks noGrp="1"/>
+          </p:cNvSpPr>
+          <p:nvPr/>
+        </p:nvSpPr>
+        <p:spPr>
+          <a:xfrm>
+            <a:off x="523875" y="5238750"/>
+            <a:ext cx="10620375" cy="352425"/>
+          </a:xfrm>
+          <a:prstGeom prst="rect">
+            <a:avLst/>
+          </a:prstGeom>
+          <a:noFill/>
+          <a:ln w="0">
+            <a:noFill/>
+          </a:ln>
+        </p:spPr>
+        <p:txBody>
+          <a:bodyPr lIns="0" tIns="0" rIns="0" bIns="0" anchor="ctr">
+            <a:normAutofit/>
+          </a:bodyPr>
+          <a:lstStyle/>
+          <a:p>
+            <a:pPr algn="l">
+              <a:defRPr sz="1575" b="1">
+                <a:solidFill>
+                  <a:srgbClr val="151515"/>
+                </a:solidFill>
+                <a:latin typeface="微软雅黑" panose="020B0503020204020204" charset="-122"/>
+                <a:ea typeface="微软雅黑" panose="020B0503020204020204" charset="-122"/>
+                <a:cs typeface="微软雅黑" panose="020B0503020204020204" charset="-122"/>
+              </a:defRPr>
+            </a:pPr>
+            <a:r>
+              <a:rPr sz="1600" b="1">
+                <a:solidFill>
+                  <a:srgbClr val="151515"/>
+                </a:solidFill>
+                <a:latin typeface="微软雅黑" panose="020B0503020204020204" charset="-122"/>
+                <a:ea typeface="微软雅黑" panose="020B0503020204020204" charset="-122"/>
+                <a:cs typeface="微软雅黑" panose="020B0503020204020204" charset="-122"/>
+              </a:rPr>
+              <a:t>RAM命中：直接复用　　SSD命中：比较恢复与重算　　未命中：重算</a:t>
+            </a:r>
+            <a:endParaRPr sz="1600" b="1">
+              <a:solidFill>
+                <a:srgbClr val="151515"/>
+              </a:solidFill>
+              <a:latin typeface="微软雅黑" panose="020B0503020204020204" charset="-122"/>
+              <a:ea typeface="微软雅黑" panose="020B0503020204020204" charset="-122"/>
+              <a:cs typeface="微软雅黑" panose="020B0503020204020204" charset="-122"/>
+            </a:endParaRPr>
+          </a:p>
+        </p:txBody>
+      </p:sp>
+      <p:sp>
+        <p:nvSpPr>
+          <p:cNvPr id="27" name="矩形 26"/>
+          <p:cNvSpPr>
+            <a:spLocks noGrp="1"/>
+          </p:cNvSpPr>
+          <p:nvPr/>
+        </p:nvSpPr>
+        <p:spPr>
+          <a:xfrm>
+            <a:off x="8214995" y="1784350"/>
+            <a:ext cx="3790950" cy="3829050"/>
+          </a:xfrm>
+          <a:prstGeom prst="rect">
+            <a:avLst/>
+          </a:prstGeom>
+          <a:solidFill>
+            <a:srgbClr val="FFFFFF"/>
+          </a:solidFill>
+          <a:ln w="14288">
+            <a:solidFill>
+              <a:srgbClr val="151515"/>
+            </a:solidFill>
+            <a:prstDash val="solid"/>
+          </a:ln>
+        </p:spPr>
+        <p:txBody>
+          <a:bodyPr/>
+          <a:p>
+            <a:endParaRPr lang="zh-CN" altLang="en-US"/>
+          </a:p>
+        </p:txBody>
+      </p:sp>
+      <p:sp>
+        <p:nvSpPr>
+          <p:cNvPr id="28" name="矩形 27"/>
+          <p:cNvSpPr>
+            <a:spLocks noGrp="1"/>
+          </p:cNvSpPr>
+          <p:nvPr/>
+        </p:nvSpPr>
+        <p:spPr>
+          <a:xfrm>
+            <a:off x="8405495" y="1908175"/>
+            <a:ext cx="3390900" cy="323850"/>
+          </a:xfrm>
+          <a:prstGeom prst="rect">
+            <a:avLst/>
+          </a:prstGeom>
+          <a:noFill/>
+          <a:ln w="0">
+            <a:noFill/>
+          </a:ln>
+        </p:spPr>
+        <p:txBody>
+          <a:bodyPr lIns="0" tIns="0" rIns="0" bIns="0" anchor="ctr">
+            <a:normAutofit/>
+          </a:bodyPr>
+          <a:lstStyle/>
+          <a:p>
+            <a:pPr algn="l">
+              <a:defRPr sz="1725" b="1">
+                <a:solidFill>
+                  <a:srgbClr val="31569C"/>
+                </a:solidFill>
+                <a:latin typeface="微软雅黑" panose="020B0503020204020204" charset="-122"/>
+                <a:ea typeface="微软雅黑" panose="020B0503020204020204" charset="-122"/>
+                <a:cs typeface="微软雅黑" panose="020B0503020204020204" charset="-122"/>
+              </a:defRPr>
+            </a:pPr>
+            <a:r>
+              <a:rPr sz="1725" b="1">
+                <a:solidFill>
+                  <a:srgbClr val="31569C"/>
+                </a:solidFill>
+                <a:latin typeface="微软雅黑" panose="020B0503020204020204" charset="-122"/>
+                <a:ea typeface="微软雅黑" panose="020B0503020204020204" charset="-122"/>
+                <a:cs typeface="微软雅黑" panose="020B0503020204020204" charset="-122"/>
+              </a:rPr>
+              <a:t>三个研究任务</a:t>
+            </a:r>
+            <a:endParaRPr sz="1725" b="1">
+              <a:solidFill>
+                <a:srgbClr val="31569C"/>
+              </a:solidFill>
+              <a:latin typeface="微软雅黑" panose="020B0503020204020204" charset="-122"/>
+              <a:ea typeface="微软雅黑" panose="020B0503020204020204" charset="-122"/>
+              <a:cs typeface="微软雅黑" panose="020B0503020204020204" charset="-122"/>
+            </a:endParaRPr>
+          </a:p>
+        </p:txBody>
+      </p:sp>
+      <p:sp>
+        <p:nvSpPr>
+          <p:cNvPr id="31" name="矩形 30"/>
+          <p:cNvSpPr>
+            <a:spLocks noGrp="1"/>
+          </p:cNvSpPr>
+          <p:nvPr/>
+        </p:nvSpPr>
+        <p:spPr>
+          <a:xfrm>
+            <a:off x="8405495" y="2317750"/>
+            <a:ext cx="3352800" cy="304800"/>
+          </a:xfrm>
+          <a:prstGeom prst="rect">
+            <a:avLst/>
+          </a:prstGeom>
+          <a:noFill/>
+          <a:ln w="0">
+            <a:noFill/>
+          </a:ln>
+        </p:spPr>
+        <p:txBody>
+          <a:bodyPr lIns="0" tIns="0" rIns="0" bIns="0" anchor="ctr">
+            <a:normAutofit/>
+          </a:bodyPr>
+          <a:lstStyle/>
+          <a:p>
+            <a:pPr algn="l">
+              <a:defRPr sz="1500" b="1">
+                <a:solidFill>
+                  <a:srgbClr val="151515"/>
+                </a:solidFill>
+                <a:latin typeface="微软雅黑" panose="020B0503020204020204" charset="-122"/>
+                <a:ea typeface="微软雅黑" panose="020B0503020204020204" charset="-122"/>
+                <a:cs typeface="微软雅黑" panose="020B0503020204020204" charset="-122"/>
+              </a:defRPr>
+            </a:pPr>
+            <a:r>
+              <a:rPr sz="1500" b="1">
+                <a:solidFill>
+                  <a:srgbClr val="151515"/>
+                </a:solidFill>
+                <a:latin typeface="微软雅黑" panose="020B0503020204020204" charset="-122"/>
+                <a:ea typeface="微软雅黑" panose="020B0503020204020204" charset="-122"/>
+                <a:cs typeface="微软雅黑" panose="020B0503020204020204" charset="-122"/>
+              </a:rPr>
+              <a:t>1  状态能否正确恢复</a:t>
+            </a:r>
+            <a:endParaRPr sz="1500" b="1">
+              <a:solidFill>
+                <a:srgbClr val="151515"/>
+              </a:solidFill>
+              <a:latin typeface="微软雅黑" panose="020B0503020204020204" charset="-122"/>
+              <a:ea typeface="微软雅黑" panose="020B0503020204020204" charset="-122"/>
+              <a:cs typeface="微软雅黑" panose="020B0503020204020204" charset="-122"/>
+            </a:endParaRPr>
+          </a:p>
+        </p:txBody>
+      </p:sp>
+      <p:sp>
+        <p:nvSpPr>
+          <p:cNvPr id="43" name="矩形 42"/>
+          <p:cNvSpPr>
+            <a:spLocks noGrp="1"/>
+          </p:cNvSpPr>
+          <p:nvPr/>
+        </p:nvSpPr>
+        <p:spPr>
+          <a:xfrm>
+            <a:off x="8405495" y="2660650"/>
+            <a:ext cx="3352800" cy="400050"/>
+          </a:xfrm>
+          <a:prstGeom prst="rect">
+            <a:avLst/>
+          </a:prstGeom>
+          <a:noFill/>
+          <a:ln w="0">
+            <a:noFill/>
+          </a:ln>
+        </p:spPr>
+        <p:txBody>
+          <a:bodyPr lIns="0" tIns="0" rIns="0" bIns="0" anchor="ctr">
+            <a:normAutofit lnSpcReduction="10000"/>
+          </a:bodyPr>
+          <a:lstStyle/>
+          <a:p>
+            <a:pPr algn="l">
+              <a:defRPr sz="1275" b="0">
+                <a:solidFill>
+                  <a:srgbClr val="151515"/>
+                </a:solidFill>
+                <a:latin typeface="微软雅黑" panose="020B0503020204020204" charset="-122"/>
+                <a:ea typeface="微软雅黑" panose="020B0503020204020204" charset="-122"/>
+                <a:cs typeface="微软雅黑" panose="020B0503020204020204" charset="-122"/>
+              </a:defRPr>
+            </a:pPr>
+            <a:r>
+              <a:rPr sz="1275" b="0">
+                <a:solidFill>
+                  <a:srgbClr val="151515"/>
+                </a:solidFill>
+                <a:latin typeface="微软雅黑" panose="020B0503020204020204" charset="-122"/>
+                <a:ea typeface="微软雅黑" panose="020B0503020204020204" charset="-122"/>
+                <a:cs typeface="微软雅黑" panose="020B0503020204020204" charset="-122"/>
+              </a:rPr>
+              <a:t>实现前缀匹配和KV保存、导入，</a:t>
+            </a:r>
+            <a:endParaRPr sz="1275" b="0">
+              <a:solidFill>
+                <a:srgbClr val="151515"/>
+              </a:solidFill>
+              <a:latin typeface="微软雅黑" panose="020B0503020204020204" charset="-122"/>
+              <a:ea typeface="微软雅黑" panose="020B0503020204020204" charset="-122"/>
+              <a:cs typeface="微软雅黑" panose="020B0503020204020204" charset="-122"/>
+            </a:endParaRPr>
+          </a:p>
+          <a:p>
+            <a:pPr algn="l">
+              <a:defRPr sz="1275" b="0">
+                <a:solidFill>
+                  <a:srgbClr val="151515"/>
+                </a:solidFill>
+                <a:latin typeface="微软雅黑" panose="020B0503020204020204" charset="-122"/>
+                <a:ea typeface="微软雅黑" panose="020B0503020204020204" charset="-122"/>
+                <a:cs typeface="微软雅黑" panose="020B0503020204020204" charset="-122"/>
+              </a:defRPr>
+            </a:pPr>
+            <a:r>
+              <a:rPr sz="1275" b="0">
+                <a:solidFill>
+                  <a:srgbClr val="151515"/>
+                </a:solidFill>
+                <a:latin typeface="微软雅黑" panose="020B0503020204020204" charset="-122"/>
+                <a:ea typeface="微软雅黑" panose="020B0503020204020204" charset="-122"/>
+                <a:cs typeface="微软雅黑" panose="020B0503020204020204" charset="-122"/>
+              </a:rPr>
+              <a:t>用同一输入的logits对照验证。</a:t>
+            </a:r>
+            <a:endParaRPr sz="1275" b="0">
+              <a:solidFill>
+                <a:srgbClr val="151515"/>
+              </a:solidFill>
+              <a:latin typeface="微软雅黑" panose="020B0503020204020204" charset="-122"/>
+              <a:ea typeface="微软雅黑" panose="020B0503020204020204" charset="-122"/>
+              <a:cs typeface="微软雅黑" panose="020B0503020204020204" charset="-122"/>
+            </a:endParaRPr>
+          </a:p>
+        </p:txBody>
+      </p:sp>
+      <p:sp>
+        <p:nvSpPr>
+          <p:cNvPr id="44" name="矩形 43"/>
+          <p:cNvSpPr>
+            <a:spLocks noGrp="1"/>
+          </p:cNvSpPr>
+          <p:nvPr/>
+        </p:nvSpPr>
+        <p:spPr>
+          <a:xfrm>
+            <a:off x="8405495" y="3279775"/>
+            <a:ext cx="3352800" cy="304800"/>
+          </a:xfrm>
+          <a:prstGeom prst="rect">
+            <a:avLst/>
+          </a:prstGeom>
+          <a:noFill/>
+          <a:ln w="0">
+            <a:noFill/>
+          </a:ln>
+        </p:spPr>
+        <p:txBody>
+          <a:bodyPr lIns="0" tIns="0" rIns="0" bIns="0" anchor="ctr">
+            <a:normAutofit/>
+          </a:bodyPr>
+          <a:lstStyle/>
+          <a:p>
+            <a:pPr algn="l">
+              <a:defRPr sz="1500" b="1">
+                <a:solidFill>
+                  <a:srgbClr val="151515"/>
+                </a:solidFill>
+                <a:latin typeface="微软雅黑" panose="020B0503020204020204" charset="-122"/>
+                <a:ea typeface="微软雅黑" panose="020B0503020204020204" charset="-122"/>
+                <a:cs typeface="微软雅黑" panose="020B0503020204020204" charset="-122"/>
+              </a:defRPr>
+            </a:pPr>
+            <a:r>
+              <a:rPr sz="1500" b="1">
+                <a:solidFill>
+                  <a:srgbClr val="151515"/>
+                </a:solidFill>
+                <a:latin typeface="微软雅黑" panose="020B0503020204020204" charset="-122"/>
+                <a:ea typeface="微软雅黑" panose="020B0503020204020204" charset="-122"/>
+                <a:cs typeface="微软雅黑" panose="020B0503020204020204" charset="-122"/>
+              </a:rPr>
+              <a:t>2  读取何时快于重算</a:t>
+            </a:r>
+            <a:endParaRPr sz="1500" b="1">
+              <a:solidFill>
+                <a:srgbClr val="151515"/>
+              </a:solidFill>
+              <a:latin typeface="微软雅黑" panose="020B0503020204020204" charset="-122"/>
+              <a:ea typeface="微软雅黑" panose="020B0503020204020204" charset="-122"/>
+              <a:cs typeface="微软雅黑" panose="020B0503020204020204" charset="-122"/>
+            </a:endParaRPr>
+          </a:p>
+        </p:txBody>
+      </p:sp>
+      <p:sp>
+        <p:nvSpPr>
+          <p:cNvPr id="45" name="矩形 44"/>
+          <p:cNvSpPr>
+            <a:spLocks noGrp="1"/>
+          </p:cNvSpPr>
+          <p:nvPr/>
+        </p:nvSpPr>
+        <p:spPr>
+          <a:xfrm>
+            <a:off x="8405495" y="3632200"/>
+            <a:ext cx="3352800" cy="495300"/>
+          </a:xfrm>
+          <a:prstGeom prst="rect">
+            <a:avLst/>
+          </a:prstGeom>
+          <a:noFill/>
+          <a:ln w="0">
+            <a:noFill/>
+          </a:ln>
+        </p:spPr>
+        <p:txBody>
+          <a:bodyPr lIns="0" tIns="0" rIns="0" bIns="0" anchor="ctr">
+            <a:normAutofit/>
+          </a:bodyPr>
+          <a:lstStyle/>
+          <a:p>
+            <a:pPr algn="l">
+              <a:defRPr sz="1275" b="0">
+                <a:solidFill>
+                  <a:srgbClr val="151515"/>
+                </a:solidFill>
+                <a:latin typeface="微软雅黑" panose="020B0503020204020204" charset="-122"/>
+                <a:ea typeface="微软雅黑" panose="020B0503020204020204" charset="-122"/>
+                <a:cs typeface="微软雅黑" panose="020B0503020204020204" charset="-122"/>
+              </a:defRPr>
+            </a:pPr>
+            <a:r>
+              <a:rPr sz="1275" b="0">
+                <a:solidFill>
+                  <a:srgbClr val="151515"/>
+                </a:solidFill>
+                <a:latin typeface="微软雅黑" panose="020B0503020204020204" charset="-122"/>
+                <a:ea typeface="微软雅黑" panose="020B0503020204020204" charset="-122"/>
+                <a:cs typeface="微软雅黑" panose="020B0503020204020204" charset="-122"/>
+              </a:rPr>
+              <a:t>测SSD读取与恢复、CPU Prefill耗时，</a:t>
+            </a:r>
+            <a:endParaRPr sz="1275" b="0">
+              <a:solidFill>
+                <a:srgbClr val="151515"/>
+              </a:solidFill>
+              <a:latin typeface="微软雅黑" panose="020B0503020204020204" charset="-122"/>
+              <a:ea typeface="微软雅黑" panose="020B0503020204020204" charset="-122"/>
+              <a:cs typeface="微软雅黑" panose="020B0503020204020204" charset="-122"/>
+            </a:endParaRPr>
+          </a:p>
+          <a:p>
+            <a:pPr algn="l">
+              <a:defRPr sz="1275" b="0">
+                <a:solidFill>
+                  <a:srgbClr val="151515"/>
+                </a:solidFill>
+                <a:latin typeface="微软雅黑" panose="020B0503020204020204" charset="-122"/>
+                <a:ea typeface="微软雅黑" panose="020B0503020204020204" charset="-122"/>
+                <a:cs typeface="微软雅黑" panose="020B0503020204020204" charset="-122"/>
+              </a:defRPr>
+            </a:pPr>
+            <a:r>
+              <a:rPr sz="1275" b="0">
+                <a:solidFill>
+                  <a:srgbClr val="151515"/>
+                </a:solidFill>
+                <a:latin typeface="微软雅黑" panose="020B0503020204020204" charset="-122"/>
+                <a:ea typeface="微软雅黑" panose="020B0503020204020204" charset="-122"/>
+                <a:cs typeface="微软雅黑" panose="020B0503020204020204" charset="-122"/>
+              </a:rPr>
+              <a:t>同时检查RAM能否容纳所需状态。</a:t>
+            </a:r>
+            <a:endParaRPr sz="1275" b="0">
+              <a:solidFill>
+                <a:srgbClr val="151515"/>
+              </a:solidFill>
+              <a:latin typeface="微软雅黑" panose="020B0503020204020204" charset="-122"/>
+              <a:ea typeface="微软雅黑" panose="020B0503020204020204" charset="-122"/>
+              <a:cs typeface="微软雅黑" panose="020B0503020204020204" charset="-122"/>
+            </a:endParaRPr>
+          </a:p>
+        </p:txBody>
+      </p:sp>
+      <p:sp>
+        <p:nvSpPr>
+          <p:cNvPr id="46" name="矩形 45"/>
+          <p:cNvSpPr>
+            <a:spLocks noGrp="1"/>
+          </p:cNvSpPr>
+          <p:nvPr/>
+        </p:nvSpPr>
+        <p:spPr>
+          <a:xfrm>
+            <a:off x="8405495" y="4394200"/>
+            <a:ext cx="3352800" cy="304800"/>
+          </a:xfrm>
+          <a:prstGeom prst="rect">
+            <a:avLst/>
+          </a:prstGeom>
+          <a:noFill/>
+          <a:ln w="0">
+            <a:noFill/>
+          </a:ln>
+        </p:spPr>
+        <p:txBody>
+          <a:bodyPr lIns="0" tIns="0" rIns="0" bIns="0" anchor="ctr">
+            <a:normAutofit/>
+          </a:bodyPr>
+          <a:lstStyle/>
+          <a:p>
+            <a:pPr algn="l">
+              <a:defRPr sz="1500" b="1">
+                <a:solidFill>
+                  <a:srgbClr val="151515"/>
+                </a:solidFill>
+                <a:latin typeface="微软雅黑" panose="020B0503020204020204" charset="-122"/>
+                <a:ea typeface="微软雅黑" panose="020B0503020204020204" charset="-122"/>
+                <a:cs typeface="微软雅黑" panose="020B0503020204020204" charset="-122"/>
+              </a:defRPr>
+            </a:pPr>
+            <a:r>
+              <a:rPr sz="1500" b="1">
+                <a:solidFill>
+                  <a:srgbClr val="151515"/>
+                </a:solidFill>
+                <a:latin typeface="微软雅黑" panose="020B0503020204020204" charset="-122"/>
+                <a:ea typeface="微软雅黑" panose="020B0503020204020204" charset="-122"/>
+                <a:cs typeface="微软雅黑" panose="020B0503020204020204" charset="-122"/>
+              </a:rPr>
+              <a:t>3  预取与写入怎样干扰请求</a:t>
+            </a:r>
+            <a:endParaRPr sz="1500" b="1">
+              <a:solidFill>
+                <a:srgbClr val="151515"/>
+              </a:solidFill>
+              <a:latin typeface="微软雅黑" panose="020B0503020204020204" charset="-122"/>
+              <a:ea typeface="微软雅黑" panose="020B0503020204020204" charset="-122"/>
+              <a:cs typeface="微软雅黑" panose="020B0503020204020204" charset="-122"/>
+            </a:endParaRPr>
+          </a:p>
+        </p:txBody>
+      </p:sp>
+      <p:sp>
+        <p:nvSpPr>
+          <p:cNvPr id="47" name="矩形 46"/>
+          <p:cNvSpPr>
+            <a:spLocks noGrp="1"/>
+          </p:cNvSpPr>
+          <p:nvPr/>
+        </p:nvSpPr>
+        <p:spPr>
+          <a:xfrm>
+            <a:off x="8405495" y="4756150"/>
+            <a:ext cx="3352800" cy="552450"/>
+          </a:xfrm>
+          <a:prstGeom prst="rect">
+            <a:avLst/>
+          </a:prstGeom>
+          <a:noFill/>
+          <a:ln w="0">
+            <a:noFill/>
+          </a:ln>
+        </p:spPr>
+        <p:txBody>
+          <a:bodyPr lIns="0" tIns="0" rIns="0" bIns="0" anchor="ctr">
+            <a:normAutofit/>
+          </a:bodyPr>
+          <a:lstStyle/>
+          <a:p>
+            <a:pPr algn="l">
+              <a:defRPr sz="1275" b="0">
+                <a:solidFill>
+                  <a:srgbClr val="151515"/>
+                </a:solidFill>
+                <a:latin typeface="微软雅黑" panose="020B0503020204020204" charset="-122"/>
+                <a:ea typeface="微软雅黑" panose="020B0503020204020204" charset="-122"/>
+                <a:cs typeface="微软雅黑" panose="020B0503020204020204" charset="-122"/>
+              </a:defRPr>
+            </a:pPr>
+            <a:r>
+              <a:rPr sz="1275" b="0">
+                <a:solidFill>
+                  <a:srgbClr val="151515"/>
+                </a:solidFill>
+                <a:latin typeface="微软雅黑" panose="020B0503020204020204" charset="-122"/>
+                <a:ea typeface="微软雅黑" panose="020B0503020204020204" charset="-122"/>
+                <a:cs typeface="微软雅黑" panose="020B0503020204020204" charset="-122"/>
+              </a:rPr>
+              <a:t>比较等待策略，限制后台写入占用，</a:t>
+            </a:r>
+            <a:endParaRPr sz="1275" b="0">
+              <a:solidFill>
+                <a:srgbClr val="151515"/>
+              </a:solidFill>
+              <a:latin typeface="微软雅黑" panose="020B0503020204020204" charset="-122"/>
+              <a:ea typeface="微软雅黑" panose="020B0503020204020204" charset="-122"/>
+              <a:cs typeface="微软雅黑" panose="020B0503020204020204" charset="-122"/>
+            </a:endParaRPr>
+          </a:p>
+          <a:p>
+            <a:pPr algn="l">
+              <a:defRPr sz="1275" b="0">
+                <a:solidFill>
+                  <a:srgbClr val="151515"/>
+                </a:solidFill>
+                <a:latin typeface="微软雅黑" panose="020B0503020204020204" charset="-122"/>
+                <a:ea typeface="微软雅黑" panose="020B0503020204020204" charset="-122"/>
+                <a:cs typeface="微软雅黑" panose="020B0503020204020204" charset="-122"/>
+              </a:defRPr>
+            </a:pPr>
+            <a:r>
+              <a:rPr sz="1275" b="0">
+                <a:solidFill>
+                  <a:srgbClr val="151515"/>
+                </a:solidFill>
+                <a:latin typeface="微软雅黑" panose="020B0503020204020204" charset="-122"/>
+                <a:ea typeface="微软雅黑" panose="020B0503020204020204" charset="-122"/>
+                <a:cs typeface="微软雅黑" panose="020B0503020204020204" charset="-122"/>
+              </a:rPr>
+              <a:t>观察前台TTFT与I/O竞争。</a:t>
+            </a:r>
+            <a:endParaRPr sz="1275" b="0">
+              <a:solidFill>
+                <a:srgbClr val="151515"/>
+              </a:solidFill>
+              <a:latin typeface="微软雅黑" panose="020B0503020204020204" charset="-122"/>
+              <a:ea typeface="微软雅黑" panose="020B0503020204020204" charset="-122"/>
+              <a:cs typeface="微软雅黑" panose="020B0503020204020204" charset="-122"/>
+            </a:endParaRPr>
+          </a:p>
+        </p:txBody>
+      </p:sp>
       <p:pic>
         <p:nvPicPr>
-          <p:cNvPr id="25" name="图片 24" descr="CPU-only.drawio"/>
+          <p:cNvPr id="3" name="图片 2"/>
           <p:cNvPicPr>
             <a:picLocks noChangeAspect="1"/>
           </p:cNvPicPr>
@@ -6716,606 +7314,14 @@
         </p:blipFill>
         <p:spPr>
           <a:xfrm>
-            <a:off x="523875" y="1701800"/>
-            <a:ext cx="8538210" cy="2857500"/>
+            <a:off x="80010" y="1759585"/>
+            <a:ext cx="8218170" cy="4275455"/>
           </a:xfrm>
           <a:prstGeom prst="rect">
             <a:avLst/>
           </a:prstGeom>
         </p:spPr>
       </p:pic>
-      <p:sp>
-        <p:nvSpPr>
-          <p:cNvPr id="32" name="矩形 31"/>
-          <p:cNvSpPr>
-            <a:spLocks noGrp="1"/>
-          </p:cNvSpPr>
-          <p:nvPr/>
-        </p:nvSpPr>
-        <p:spPr>
-          <a:xfrm>
-            <a:off x="523875" y="5238750"/>
-            <a:ext cx="10620375" cy="352425"/>
-          </a:xfrm>
-          <a:prstGeom prst="rect">
-            <a:avLst/>
-          </a:prstGeom>
-          <a:noFill/>
-          <a:ln w="0">
-            <a:noFill/>
-          </a:ln>
-        </p:spPr>
-        <p:txBody>
-          <a:bodyPr lIns="0" tIns="0" rIns="0" bIns="0" anchor="ctr">
-            <a:normAutofit/>
-          </a:bodyPr>
-          <a:lstStyle/>
-          <a:p>
-            <a:pPr algn="l">
-              <a:defRPr sz="1575" b="1">
-                <a:solidFill>
-                  <a:srgbClr val="151515"/>
-                </a:solidFill>
-                <a:latin typeface="微软雅黑" panose="020B0503020204020204" charset="-122"/>
-                <a:ea typeface="微软雅黑" panose="020B0503020204020204" charset="-122"/>
-                <a:cs typeface="微软雅黑" panose="020B0503020204020204" charset="-122"/>
-              </a:defRPr>
-            </a:pPr>
-            <a:r>
-              <a:rPr sz="1600" b="1">
-                <a:solidFill>
-                  <a:srgbClr val="151515"/>
-                </a:solidFill>
-                <a:latin typeface="微软雅黑" panose="020B0503020204020204" charset="-122"/>
-                <a:ea typeface="微软雅黑" panose="020B0503020204020204" charset="-122"/>
-                <a:cs typeface="微软雅黑" panose="020B0503020204020204" charset="-122"/>
-              </a:rPr>
-              <a:t>RAM命中：直接复用　　SSD命中：比较恢复与重算　　未命中：重算</a:t>
-            </a:r>
-            <a:endParaRPr sz="1600" b="1">
-              <a:solidFill>
-                <a:srgbClr val="151515"/>
-              </a:solidFill>
-              <a:latin typeface="微软雅黑" panose="020B0503020204020204" charset="-122"/>
-              <a:ea typeface="微软雅黑" panose="020B0503020204020204" charset="-122"/>
-              <a:cs typeface="微软雅黑" panose="020B0503020204020204" charset="-122"/>
-            </a:endParaRPr>
-          </a:p>
-        </p:txBody>
-      </p:sp>
-      <p:sp>
-        <p:nvSpPr>
-          <p:cNvPr id="27" name="矩形 26"/>
-          <p:cNvSpPr>
-            <a:spLocks noGrp="1"/>
-          </p:cNvSpPr>
-          <p:nvPr/>
-        </p:nvSpPr>
-        <p:spPr>
-          <a:xfrm>
-            <a:off x="8214995" y="3028950"/>
-            <a:ext cx="3790950" cy="3829050"/>
-          </a:xfrm>
-          <a:prstGeom prst="rect">
-            <a:avLst/>
-          </a:prstGeom>
-          <a:solidFill>
-            <a:srgbClr val="FFFFFF"/>
-          </a:solidFill>
-          <a:ln w="14288">
-            <a:solidFill>
-              <a:srgbClr val="151515"/>
-            </a:solidFill>
-            <a:prstDash val="solid"/>
-          </a:ln>
-        </p:spPr>
-      </p:sp>
-      <p:sp>
-        <p:nvSpPr>
-          <p:cNvPr id="28" name="矩形 27"/>
-          <p:cNvSpPr>
-            <a:spLocks noGrp="1"/>
-          </p:cNvSpPr>
-          <p:nvPr/>
-        </p:nvSpPr>
-        <p:spPr>
-          <a:xfrm>
-            <a:off x="8405495" y="3152775"/>
-            <a:ext cx="3390900" cy="323850"/>
-          </a:xfrm>
-          <a:prstGeom prst="rect">
-            <a:avLst/>
-          </a:prstGeom>
-          <a:noFill/>
-          <a:ln w="0">
-            <a:noFill/>
-          </a:ln>
-        </p:spPr>
-        <p:txBody>
-          <a:bodyPr lIns="0" tIns="0" rIns="0" bIns="0" anchor="ctr">
-            <a:normAutofit/>
-          </a:bodyPr>
-          <a:lstStyle/>
-          <a:p>
-            <a:pPr algn="l">
-              <a:defRPr sz="1725" b="1">
-                <a:solidFill>
-                  <a:srgbClr val="31569C"/>
-                </a:solidFill>
-                <a:latin typeface="微软雅黑" panose="020B0503020204020204" charset="-122"/>
-                <a:ea typeface="微软雅黑" panose="020B0503020204020204" charset="-122"/>
-                <a:cs typeface="微软雅黑" panose="020B0503020204020204" charset="-122"/>
-              </a:defRPr>
-            </a:pPr>
-            <a:r>
-              <a:rPr sz="1725" b="1">
-                <a:solidFill>
-                  <a:srgbClr val="31569C"/>
-                </a:solidFill>
-                <a:latin typeface="微软雅黑" panose="020B0503020204020204" charset="-122"/>
-                <a:ea typeface="微软雅黑" panose="020B0503020204020204" charset="-122"/>
-                <a:cs typeface="微软雅黑" panose="020B0503020204020204" charset="-122"/>
-              </a:rPr>
-              <a:t>三个研究任务</a:t>
-            </a:r>
-            <a:endParaRPr sz="1725" b="1">
-              <a:solidFill>
-                <a:srgbClr val="31569C"/>
-              </a:solidFill>
-              <a:latin typeface="微软雅黑" panose="020B0503020204020204" charset="-122"/>
-              <a:ea typeface="微软雅黑" panose="020B0503020204020204" charset="-122"/>
-              <a:cs typeface="微软雅黑" panose="020B0503020204020204" charset="-122"/>
-            </a:endParaRPr>
-          </a:p>
-        </p:txBody>
-      </p:sp>
-      <p:sp>
-        <p:nvSpPr>
-          <p:cNvPr id="31" name="矩形 30"/>
-          <p:cNvSpPr>
-            <a:spLocks noGrp="1"/>
-          </p:cNvSpPr>
-          <p:nvPr/>
-        </p:nvSpPr>
-        <p:spPr>
-          <a:xfrm>
-            <a:off x="8405495" y="3562350"/>
-            <a:ext cx="3352800" cy="304800"/>
-          </a:xfrm>
-          <a:prstGeom prst="rect">
-            <a:avLst/>
-          </a:prstGeom>
-          <a:noFill/>
-          <a:ln w="0">
-            <a:noFill/>
-          </a:ln>
-        </p:spPr>
-        <p:txBody>
-          <a:bodyPr lIns="0" tIns="0" rIns="0" bIns="0" anchor="ctr">
-            <a:normAutofit/>
-          </a:bodyPr>
-          <a:lstStyle/>
-          <a:p>
-            <a:pPr algn="l">
-              <a:defRPr sz="1500" b="1">
-                <a:solidFill>
-                  <a:srgbClr val="151515"/>
-                </a:solidFill>
-                <a:latin typeface="微软雅黑" panose="020B0503020204020204" charset="-122"/>
-                <a:ea typeface="微软雅黑" panose="020B0503020204020204" charset="-122"/>
-                <a:cs typeface="微软雅黑" panose="020B0503020204020204" charset="-122"/>
-              </a:defRPr>
-            </a:pPr>
-            <a:r>
-              <a:rPr sz="1500" b="1">
-                <a:solidFill>
-                  <a:srgbClr val="151515"/>
-                </a:solidFill>
-                <a:latin typeface="微软雅黑" panose="020B0503020204020204" charset="-122"/>
-                <a:ea typeface="微软雅黑" panose="020B0503020204020204" charset="-122"/>
-                <a:cs typeface="微软雅黑" panose="020B0503020204020204" charset="-122"/>
-              </a:rPr>
-              <a:t>1  状态能否正确恢复</a:t>
-            </a:r>
-            <a:endParaRPr sz="1500" b="1">
-              <a:solidFill>
-                <a:srgbClr val="151515"/>
-              </a:solidFill>
-              <a:latin typeface="微软雅黑" panose="020B0503020204020204" charset="-122"/>
-              <a:ea typeface="微软雅黑" panose="020B0503020204020204" charset="-122"/>
-              <a:cs typeface="微软雅黑" panose="020B0503020204020204" charset="-122"/>
-            </a:endParaRPr>
-          </a:p>
-        </p:txBody>
-      </p:sp>
-      <p:sp>
-        <p:nvSpPr>
-          <p:cNvPr id="43" name="矩形 42"/>
-          <p:cNvSpPr>
-            <a:spLocks noGrp="1"/>
-          </p:cNvSpPr>
-          <p:nvPr/>
-        </p:nvSpPr>
-        <p:spPr>
-          <a:xfrm>
-            <a:off x="8405495" y="3905250"/>
-            <a:ext cx="3352800" cy="400050"/>
-          </a:xfrm>
-          <a:prstGeom prst="rect">
-            <a:avLst/>
-          </a:prstGeom>
-          <a:noFill/>
-          <a:ln w="0">
-            <a:noFill/>
-          </a:ln>
-        </p:spPr>
-        <p:txBody>
-          <a:bodyPr lIns="0" tIns="0" rIns="0" bIns="0" anchor="ctr">
-            <a:normAutofit lnSpcReduction="10000"/>
-          </a:bodyPr>
-          <a:lstStyle/>
-          <a:p>
-            <a:pPr algn="l">
-              <a:defRPr sz="1275" b="0">
-                <a:solidFill>
-                  <a:srgbClr val="151515"/>
-                </a:solidFill>
-                <a:latin typeface="微软雅黑" panose="020B0503020204020204" charset="-122"/>
-                <a:ea typeface="微软雅黑" panose="020B0503020204020204" charset="-122"/>
-                <a:cs typeface="微软雅黑" panose="020B0503020204020204" charset="-122"/>
-              </a:defRPr>
-            </a:pPr>
-            <a:r>
-              <a:rPr sz="1275" b="0">
-                <a:solidFill>
-                  <a:srgbClr val="151515"/>
-                </a:solidFill>
-                <a:latin typeface="微软雅黑" panose="020B0503020204020204" charset="-122"/>
-                <a:ea typeface="微软雅黑" panose="020B0503020204020204" charset="-122"/>
-                <a:cs typeface="微软雅黑" panose="020B0503020204020204" charset="-122"/>
-              </a:rPr>
-              <a:t>实现前缀匹配和KV保存、导入，</a:t>
-            </a:r>
-            <a:endParaRPr sz="1275" b="0">
-              <a:solidFill>
-                <a:srgbClr val="151515"/>
-              </a:solidFill>
-              <a:latin typeface="微软雅黑" panose="020B0503020204020204" charset="-122"/>
-              <a:ea typeface="微软雅黑" panose="020B0503020204020204" charset="-122"/>
-              <a:cs typeface="微软雅黑" panose="020B0503020204020204" charset="-122"/>
-            </a:endParaRPr>
-          </a:p>
-          <a:p>
-            <a:pPr algn="l">
-              <a:defRPr sz="1275" b="0">
-                <a:solidFill>
-                  <a:srgbClr val="151515"/>
-                </a:solidFill>
-                <a:latin typeface="微软雅黑" panose="020B0503020204020204" charset="-122"/>
-                <a:ea typeface="微软雅黑" panose="020B0503020204020204" charset="-122"/>
-                <a:cs typeface="微软雅黑" panose="020B0503020204020204" charset="-122"/>
-              </a:defRPr>
-            </a:pPr>
-            <a:r>
-              <a:rPr sz="1275" b="0">
-                <a:solidFill>
-                  <a:srgbClr val="151515"/>
-                </a:solidFill>
-                <a:latin typeface="微软雅黑" panose="020B0503020204020204" charset="-122"/>
-                <a:ea typeface="微软雅黑" panose="020B0503020204020204" charset="-122"/>
-                <a:cs typeface="微软雅黑" panose="020B0503020204020204" charset="-122"/>
-              </a:rPr>
-              <a:t>用同一输入的logits对照验证。</a:t>
-            </a:r>
-            <a:endParaRPr sz="1275" b="0">
-              <a:solidFill>
-                <a:srgbClr val="151515"/>
-              </a:solidFill>
-              <a:latin typeface="微软雅黑" panose="020B0503020204020204" charset="-122"/>
-              <a:ea typeface="微软雅黑" panose="020B0503020204020204" charset="-122"/>
-              <a:cs typeface="微软雅黑" panose="020B0503020204020204" charset="-122"/>
-            </a:endParaRPr>
-          </a:p>
-        </p:txBody>
-      </p:sp>
-      <p:sp>
-        <p:nvSpPr>
-          <p:cNvPr id="44" name="矩形 43"/>
-          <p:cNvSpPr>
-            <a:spLocks noGrp="1"/>
-          </p:cNvSpPr>
-          <p:nvPr/>
-        </p:nvSpPr>
-        <p:spPr>
-          <a:xfrm>
-            <a:off x="8405495" y="4524375"/>
-            <a:ext cx="3352800" cy="304800"/>
-          </a:xfrm>
-          <a:prstGeom prst="rect">
-            <a:avLst/>
-          </a:prstGeom>
-          <a:noFill/>
-          <a:ln w="0">
-            <a:noFill/>
-          </a:ln>
-        </p:spPr>
-        <p:txBody>
-          <a:bodyPr lIns="0" tIns="0" rIns="0" bIns="0" anchor="ctr">
-            <a:normAutofit/>
-          </a:bodyPr>
-          <a:lstStyle/>
-          <a:p>
-            <a:pPr algn="l">
-              <a:defRPr sz="1500" b="1">
-                <a:solidFill>
-                  <a:srgbClr val="151515"/>
-                </a:solidFill>
-                <a:latin typeface="微软雅黑" panose="020B0503020204020204" charset="-122"/>
-                <a:ea typeface="微软雅黑" panose="020B0503020204020204" charset="-122"/>
-                <a:cs typeface="微软雅黑" panose="020B0503020204020204" charset="-122"/>
-              </a:defRPr>
-            </a:pPr>
-            <a:r>
-              <a:rPr sz="1500" b="1">
-                <a:solidFill>
-                  <a:srgbClr val="151515"/>
-                </a:solidFill>
-                <a:latin typeface="微软雅黑" panose="020B0503020204020204" charset="-122"/>
-                <a:ea typeface="微软雅黑" panose="020B0503020204020204" charset="-122"/>
-                <a:cs typeface="微软雅黑" panose="020B0503020204020204" charset="-122"/>
-              </a:rPr>
-              <a:t>2  读取何时快于重算</a:t>
-            </a:r>
-            <a:endParaRPr sz="1500" b="1">
-              <a:solidFill>
-                <a:srgbClr val="151515"/>
-              </a:solidFill>
-              <a:latin typeface="微软雅黑" panose="020B0503020204020204" charset="-122"/>
-              <a:ea typeface="微软雅黑" panose="020B0503020204020204" charset="-122"/>
-              <a:cs typeface="微软雅黑" panose="020B0503020204020204" charset="-122"/>
-            </a:endParaRPr>
-          </a:p>
-        </p:txBody>
-      </p:sp>
-      <p:sp>
-        <p:nvSpPr>
-          <p:cNvPr id="45" name="矩形 44"/>
-          <p:cNvSpPr>
-            <a:spLocks noGrp="1"/>
-          </p:cNvSpPr>
-          <p:nvPr/>
-        </p:nvSpPr>
-        <p:spPr>
-          <a:xfrm>
-            <a:off x="8405495" y="4876800"/>
-            <a:ext cx="3352800" cy="495300"/>
-          </a:xfrm>
-          <a:prstGeom prst="rect">
-            <a:avLst/>
-          </a:prstGeom>
-          <a:noFill/>
-          <a:ln w="0">
-            <a:noFill/>
-          </a:ln>
-        </p:spPr>
-        <p:txBody>
-          <a:bodyPr lIns="0" tIns="0" rIns="0" bIns="0" anchor="ctr">
-            <a:normAutofit/>
-          </a:bodyPr>
-          <a:lstStyle/>
-          <a:p>
-            <a:pPr algn="l">
-              <a:defRPr sz="1275" b="0">
-                <a:solidFill>
-                  <a:srgbClr val="151515"/>
-                </a:solidFill>
-                <a:latin typeface="微软雅黑" panose="020B0503020204020204" charset="-122"/>
-                <a:ea typeface="微软雅黑" panose="020B0503020204020204" charset="-122"/>
-                <a:cs typeface="微软雅黑" panose="020B0503020204020204" charset="-122"/>
-              </a:defRPr>
-            </a:pPr>
-            <a:r>
-              <a:rPr sz="1275" b="0">
-                <a:solidFill>
-                  <a:srgbClr val="151515"/>
-                </a:solidFill>
-                <a:latin typeface="微软雅黑" panose="020B0503020204020204" charset="-122"/>
-                <a:ea typeface="微软雅黑" panose="020B0503020204020204" charset="-122"/>
-                <a:cs typeface="微软雅黑" panose="020B0503020204020204" charset="-122"/>
-              </a:rPr>
-              <a:t>测SSD读取与恢复、CPU Prefill耗时，</a:t>
-            </a:r>
-            <a:endParaRPr sz="1275" b="0">
-              <a:solidFill>
-                <a:srgbClr val="151515"/>
-              </a:solidFill>
-              <a:latin typeface="微软雅黑" panose="020B0503020204020204" charset="-122"/>
-              <a:ea typeface="微软雅黑" panose="020B0503020204020204" charset="-122"/>
-              <a:cs typeface="微软雅黑" panose="020B0503020204020204" charset="-122"/>
-            </a:endParaRPr>
-          </a:p>
-          <a:p>
-            <a:pPr algn="l">
-              <a:defRPr sz="1275" b="0">
-                <a:solidFill>
-                  <a:srgbClr val="151515"/>
-                </a:solidFill>
-                <a:latin typeface="微软雅黑" panose="020B0503020204020204" charset="-122"/>
-                <a:ea typeface="微软雅黑" panose="020B0503020204020204" charset="-122"/>
-                <a:cs typeface="微软雅黑" panose="020B0503020204020204" charset="-122"/>
-              </a:defRPr>
-            </a:pPr>
-            <a:r>
-              <a:rPr sz="1275" b="0">
-                <a:solidFill>
-                  <a:srgbClr val="151515"/>
-                </a:solidFill>
-                <a:latin typeface="微软雅黑" panose="020B0503020204020204" charset="-122"/>
-                <a:ea typeface="微软雅黑" panose="020B0503020204020204" charset="-122"/>
-                <a:cs typeface="微软雅黑" panose="020B0503020204020204" charset="-122"/>
-              </a:rPr>
-              <a:t>同时检查RAM能否容纳所需状态。</a:t>
-            </a:r>
-            <a:endParaRPr sz="1275" b="0">
-              <a:solidFill>
-                <a:srgbClr val="151515"/>
-              </a:solidFill>
-              <a:latin typeface="微软雅黑" panose="020B0503020204020204" charset="-122"/>
-              <a:ea typeface="微软雅黑" panose="020B0503020204020204" charset="-122"/>
-              <a:cs typeface="微软雅黑" panose="020B0503020204020204" charset="-122"/>
-            </a:endParaRPr>
-          </a:p>
-        </p:txBody>
-      </p:sp>
-      <p:sp>
-        <p:nvSpPr>
-          <p:cNvPr id="46" name="矩形 45"/>
-          <p:cNvSpPr>
-            <a:spLocks noGrp="1"/>
-          </p:cNvSpPr>
-          <p:nvPr/>
-        </p:nvSpPr>
-        <p:spPr>
-          <a:xfrm>
-            <a:off x="8405495" y="5638800"/>
-            <a:ext cx="3352800" cy="304800"/>
-          </a:xfrm>
-          <a:prstGeom prst="rect">
-            <a:avLst/>
-          </a:prstGeom>
-          <a:noFill/>
-          <a:ln w="0">
-            <a:noFill/>
-          </a:ln>
-        </p:spPr>
-        <p:txBody>
-          <a:bodyPr lIns="0" tIns="0" rIns="0" bIns="0" anchor="ctr">
-            <a:normAutofit/>
-          </a:bodyPr>
-          <a:lstStyle/>
-          <a:p>
-            <a:pPr algn="l">
-              <a:defRPr sz="1500" b="1">
-                <a:solidFill>
-                  <a:srgbClr val="151515"/>
-                </a:solidFill>
-                <a:latin typeface="微软雅黑" panose="020B0503020204020204" charset="-122"/>
-                <a:ea typeface="微软雅黑" panose="020B0503020204020204" charset="-122"/>
-                <a:cs typeface="微软雅黑" panose="020B0503020204020204" charset="-122"/>
-              </a:defRPr>
-            </a:pPr>
-            <a:r>
-              <a:rPr sz="1500" b="1">
-                <a:solidFill>
-                  <a:srgbClr val="151515"/>
-                </a:solidFill>
-                <a:latin typeface="微软雅黑" panose="020B0503020204020204" charset="-122"/>
-                <a:ea typeface="微软雅黑" panose="020B0503020204020204" charset="-122"/>
-                <a:cs typeface="微软雅黑" panose="020B0503020204020204" charset="-122"/>
-              </a:rPr>
-              <a:t>3  预取与写入怎样干扰请求</a:t>
-            </a:r>
-            <a:endParaRPr sz="1500" b="1">
-              <a:solidFill>
-                <a:srgbClr val="151515"/>
-              </a:solidFill>
-              <a:latin typeface="微软雅黑" panose="020B0503020204020204" charset="-122"/>
-              <a:ea typeface="微软雅黑" panose="020B0503020204020204" charset="-122"/>
-              <a:cs typeface="微软雅黑" panose="020B0503020204020204" charset="-122"/>
-            </a:endParaRPr>
-          </a:p>
-        </p:txBody>
-      </p:sp>
-      <p:sp>
-        <p:nvSpPr>
-          <p:cNvPr id="47" name="矩形 46"/>
-          <p:cNvSpPr>
-            <a:spLocks noGrp="1"/>
-          </p:cNvSpPr>
-          <p:nvPr/>
-        </p:nvSpPr>
-        <p:spPr>
-          <a:xfrm>
-            <a:off x="8405495" y="6000750"/>
-            <a:ext cx="3352800" cy="552450"/>
-          </a:xfrm>
-          <a:prstGeom prst="rect">
-            <a:avLst/>
-          </a:prstGeom>
-          <a:noFill/>
-          <a:ln w="0">
-            <a:noFill/>
-          </a:ln>
-        </p:spPr>
-        <p:txBody>
-          <a:bodyPr lIns="0" tIns="0" rIns="0" bIns="0" anchor="ctr">
-            <a:normAutofit/>
-          </a:bodyPr>
-          <a:lstStyle/>
-          <a:p>
-            <a:pPr algn="l">
-              <a:defRPr sz="1275" b="0">
-                <a:solidFill>
-                  <a:srgbClr val="151515"/>
-                </a:solidFill>
-                <a:latin typeface="微软雅黑" panose="020B0503020204020204" charset="-122"/>
-                <a:ea typeface="微软雅黑" panose="020B0503020204020204" charset="-122"/>
-                <a:cs typeface="微软雅黑" panose="020B0503020204020204" charset="-122"/>
-              </a:defRPr>
-            </a:pPr>
-            <a:r>
-              <a:rPr sz="1275" b="0">
-                <a:solidFill>
-                  <a:srgbClr val="151515"/>
-                </a:solidFill>
-                <a:latin typeface="微软雅黑" panose="020B0503020204020204" charset="-122"/>
-                <a:ea typeface="微软雅黑" panose="020B0503020204020204" charset="-122"/>
-                <a:cs typeface="微软雅黑" panose="020B0503020204020204" charset="-122"/>
-              </a:rPr>
-              <a:t>比较等待策略，限制后台写入占用，</a:t>
-            </a:r>
-            <a:endParaRPr sz="1275" b="0">
-              <a:solidFill>
-                <a:srgbClr val="151515"/>
-              </a:solidFill>
-              <a:latin typeface="微软雅黑" panose="020B0503020204020204" charset="-122"/>
-              <a:ea typeface="微软雅黑" panose="020B0503020204020204" charset="-122"/>
-              <a:cs typeface="微软雅黑" panose="020B0503020204020204" charset="-122"/>
-            </a:endParaRPr>
-          </a:p>
-          <a:p>
-            <a:pPr algn="l">
-              <a:defRPr sz="1275" b="0">
-                <a:solidFill>
-                  <a:srgbClr val="151515"/>
-                </a:solidFill>
-                <a:latin typeface="微软雅黑" panose="020B0503020204020204" charset="-122"/>
-                <a:ea typeface="微软雅黑" panose="020B0503020204020204" charset="-122"/>
-                <a:cs typeface="微软雅黑" panose="020B0503020204020204" charset="-122"/>
-              </a:defRPr>
-            </a:pPr>
-            <a:r>
-              <a:rPr sz="1275" b="0">
-                <a:solidFill>
-                  <a:srgbClr val="151515"/>
-                </a:solidFill>
-                <a:latin typeface="微软雅黑" panose="020B0503020204020204" charset="-122"/>
-                <a:ea typeface="微软雅黑" panose="020B0503020204020204" charset="-122"/>
-                <a:cs typeface="微软雅黑" panose="020B0503020204020204" charset="-122"/>
-              </a:rPr>
-              <a:t>观察前台TTFT与I/O竞争。</a:t>
-            </a:r>
-            <a:endParaRPr sz="1275" b="0">
-              <a:solidFill>
-                <a:srgbClr val="151515"/>
-              </a:solidFill>
-              <a:latin typeface="微软雅黑" panose="020B0503020204020204" charset="-122"/>
-              <a:ea typeface="微软雅黑" panose="020B0503020204020204" charset="-122"/>
-              <a:cs typeface="微软雅黑" panose="020B0503020204020204" charset="-122"/>
-            </a:endParaRPr>
-          </a:p>
-        </p:txBody>
-      </p:sp>
     </p:spTree>
     <p:custDataLst>
       <p:tags r:id="rId2"/>

</xml_diff>